<commit_message>
AutomaTivio: Mercado de Crédito preenche a folha, caixa do T na tela, logos do e-mail menores
- Mercado de Crédito: com poucos setores (tabela IPCA) o painel ocupa a
  altura livre até a nota e as linhas crescem; o total da tabela larga em
  corpo menor para os números não encostarem.
- Caixa do T: sai a regra antiga do relatorio_vertical.html que a deixava
  transparente na tela e na exportação PNG/JPG.
- E-mail: logos em 30 px (Crédito Privado) e 44 px (ALT).

Co-Authored-By: Claude Opus 5.5 <noreply@anthropic.com>
</commit_message>
<xml_diff>
--- a/AutomaTivio/saida/2026-08/pptx/Tivio Esplanada - Relatório de Gestão - Agosto 2026.pptx
+++ b/AutomaTivio/saida/2026-08/pptx/Tivio Esplanada - Relatório de Gestão - Agosto 2026.pptx
@@ -6666,25 +6666,25 @@
         </p:nvSpPr>
         <p:spPr>
           <a:xfrm>
-            <a:off x="2020410" y="2175390"/>
-            <a:ext cx="619164" cy="173880"/>
-          </a:xfrm>
-          <a:prstGeom prst="rect">
-            <a:avLst/>
-          </a:prstGeom>
-          <a:noFill/>
-        </p:spPr>
-        <p:txBody>
-          <a:bodyPr wrap="none" lIns="0" rIns="0" tIns="0" bIns="0" anchor="t"/>
-          <a:lstStyle/>
-          <a:p>
-            <a:pPr algn="ctr">
-              <a:lnSpc>
-                <a:spcPts val="1357"/>
-              </a:lnSpc>
-            </a:pPr>
-            <a:r>
-              <a:rPr sz="1131" b="1" i="0">
+            <a:off x="2020410" y="2190510"/>
+            <a:ext cx="536117" cy="143640"/>
+          </a:xfrm>
+          <a:prstGeom prst="rect">
+            <a:avLst/>
+          </a:prstGeom>
+          <a:noFill/>
+        </p:spPr>
+        <p:txBody>
+          <a:bodyPr wrap="none" lIns="0" rIns="0" tIns="0" bIns="0" anchor="t"/>
+          <a:lstStyle/>
+          <a:p>
+            <a:pPr algn="ctr">
+              <a:lnSpc>
+                <a:spcPts val="1107"/>
+              </a:lnSpc>
+            </a:pPr>
+            <a:r>
+              <a:rPr sz="922" b="1" i="0">
                 <a:solidFill>
                   <a:srgbClr val="FFFFFF"/>
                 </a:solidFill>
@@ -6703,25 +6703,25 @@
         </p:nvSpPr>
         <p:spPr>
           <a:xfrm>
-            <a:off x="2581267" y="2175390"/>
-            <a:ext cx="536117" cy="173880"/>
-          </a:xfrm>
-          <a:prstGeom prst="rect">
-            <a:avLst/>
-          </a:prstGeom>
-          <a:noFill/>
-        </p:spPr>
-        <p:txBody>
-          <a:bodyPr wrap="none" lIns="0" rIns="0" tIns="0" bIns="0" anchor="t"/>
-          <a:lstStyle/>
-          <a:p>
-            <a:pPr algn="ctr">
-              <a:lnSpc>
-                <a:spcPts val="1357"/>
-              </a:lnSpc>
-            </a:pPr>
-            <a:r>
-              <a:rPr sz="1131" b="1" i="0">
+            <a:off x="2581267" y="2190510"/>
+            <a:ext cx="536117" cy="143640"/>
+          </a:xfrm>
+          <a:prstGeom prst="rect">
+            <a:avLst/>
+          </a:prstGeom>
+          <a:noFill/>
+        </p:spPr>
+        <p:txBody>
+          <a:bodyPr wrap="none" lIns="0" rIns="0" tIns="0" bIns="0" anchor="t"/>
+          <a:lstStyle/>
+          <a:p>
+            <a:pPr algn="ctr">
+              <a:lnSpc>
+                <a:spcPts val="1107"/>
+              </a:lnSpc>
+            </a:pPr>
+            <a:r>
+              <a:rPr sz="922" b="1" i="0">
                 <a:solidFill>
                   <a:srgbClr val="FFFFFF"/>
                 </a:solidFill>
@@ -6740,25 +6740,25 @@
         </p:nvSpPr>
         <p:spPr>
           <a:xfrm>
-            <a:off x="3142125" y="2175390"/>
-            <a:ext cx="536117" cy="173880"/>
-          </a:xfrm>
-          <a:prstGeom prst="rect">
-            <a:avLst/>
-          </a:prstGeom>
-          <a:noFill/>
-        </p:spPr>
-        <p:txBody>
-          <a:bodyPr wrap="none" lIns="0" rIns="0" tIns="0" bIns="0" anchor="t"/>
-          <a:lstStyle/>
-          <a:p>
-            <a:pPr algn="ctr">
-              <a:lnSpc>
-                <a:spcPts val="1357"/>
-              </a:lnSpc>
-            </a:pPr>
-            <a:r>
-              <a:rPr sz="1131" b="1" i="0">
+            <a:off x="3142125" y="2190510"/>
+            <a:ext cx="536117" cy="143640"/>
+          </a:xfrm>
+          <a:prstGeom prst="rect">
+            <a:avLst/>
+          </a:prstGeom>
+          <a:noFill/>
+        </p:spPr>
+        <p:txBody>
+          <a:bodyPr wrap="none" lIns="0" rIns="0" tIns="0" bIns="0" anchor="t"/>
+          <a:lstStyle/>
+          <a:p>
+            <a:pPr algn="ctr">
+              <a:lnSpc>
+                <a:spcPts val="1107"/>
+              </a:lnSpc>
+            </a:pPr>
+            <a:r>
+              <a:rPr sz="922" b="1" i="0">
                 <a:solidFill>
                   <a:srgbClr val="FFFFFF"/>
                 </a:solidFill>
@@ -6777,25 +6777,25 @@
         </p:nvSpPr>
         <p:spPr>
           <a:xfrm>
-            <a:off x="3702982" y="2175390"/>
-            <a:ext cx="536117" cy="173880"/>
-          </a:xfrm>
-          <a:prstGeom prst="rect">
-            <a:avLst/>
-          </a:prstGeom>
-          <a:noFill/>
-        </p:spPr>
-        <p:txBody>
-          <a:bodyPr wrap="none" lIns="0" rIns="0" tIns="0" bIns="0" anchor="t"/>
-          <a:lstStyle/>
-          <a:p>
-            <a:pPr algn="ctr">
-              <a:lnSpc>
-                <a:spcPts val="1357"/>
-              </a:lnSpc>
-            </a:pPr>
-            <a:r>
-              <a:rPr sz="1131" b="1" i="0">
+            <a:off x="3702982" y="2190510"/>
+            <a:ext cx="536117" cy="143640"/>
+          </a:xfrm>
+          <a:prstGeom prst="rect">
+            <a:avLst/>
+          </a:prstGeom>
+          <a:noFill/>
+        </p:spPr>
+        <p:txBody>
+          <a:bodyPr wrap="none" lIns="0" rIns="0" tIns="0" bIns="0" anchor="t"/>
+          <a:lstStyle/>
+          <a:p>
+            <a:pPr algn="ctr">
+              <a:lnSpc>
+                <a:spcPts val="1107"/>
+              </a:lnSpc>
+            </a:pPr>
+            <a:r>
+              <a:rPr sz="922" b="1" i="0">
                 <a:solidFill>
                   <a:srgbClr val="FFFFFF"/>
                 </a:solidFill>
@@ -6814,25 +6814,25 @@
         </p:nvSpPr>
         <p:spPr>
           <a:xfrm>
-            <a:off x="4263840" y="2175390"/>
-            <a:ext cx="536117" cy="173880"/>
-          </a:xfrm>
-          <a:prstGeom prst="rect">
-            <a:avLst/>
-          </a:prstGeom>
-          <a:noFill/>
-        </p:spPr>
-        <p:txBody>
-          <a:bodyPr wrap="none" lIns="0" rIns="0" tIns="0" bIns="0" anchor="t"/>
-          <a:lstStyle/>
-          <a:p>
-            <a:pPr algn="ctr">
-              <a:lnSpc>
-                <a:spcPts val="1357"/>
-              </a:lnSpc>
-            </a:pPr>
-            <a:r>
-              <a:rPr sz="1131" b="1" i="0">
+            <a:off x="4263840" y="2190510"/>
+            <a:ext cx="536117" cy="143640"/>
+          </a:xfrm>
+          <a:prstGeom prst="rect">
+            <a:avLst/>
+          </a:prstGeom>
+          <a:noFill/>
+        </p:spPr>
+        <p:txBody>
+          <a:bodyPr wrap="none" lIns="0" rIns="0" tIns="0" bIns="0" anchor="t"/>
+          <a:lstStyle/>
+          <a:p>
+            <a:pPr algn="ctr">
+              <a:lnSpc>
+                <a:spcPts val="1107"/>
+              </a:lnSpc>
+            </a:pPr>
+            <a:r>
+              <a:rPr sz="922" b="1" i="0">
                 <a:solidFill>
                   <a:srgbClr val="FFFFFF"/>
                 </a:solidFill>
@@ -6851,25 +6851,25 @@
         </p:nvSpPr>
         <p:spPr>
           <a:xfrm>
-            <a:off x="4824697" y="2175390"/>
-            <a:ext cx="536117" cy="173880"/>
-          </a:xfrm>
-          <a:prstGeom prst="rect">
-            <a:avLst/>
-          </a:prstGeom>
-          <a:noFill/>
-        </p:spPr>
-        <p:txBody>
-          <a:bodyPr wrap="none" lIns="0" rIns="0" tIns="0" bIns="0" anchor="t"/>
-          <a:lstStyle/>
-          <a:p>
-            <a:pPr algn="ctr">
-              <a:lnSpc>
-                <a:spcPts val="1357"/>
-              </a:lnSpc>
-            </a:pPr>
-            <a:r>
-              <a:rPr sz="1131" b="1" i="0">
+            <a:off x="4824697" y="2190510"/>
+            <a:ext cx="536117" cy="143640"/>
+          </a:xfrm>
+          <a:prstGeom prst="rect">
+            <a:avLst/>
+          </a:prstGeom>
+          <a:noFill/>
+        </p:spPr>
+        <p:txBody>
+          <a:bodyPr wrap="none" lIns="0" rIns="0" tIns="0" bIns="0" anchor="t"/>
+          <a:lstStyle/>
+          <a:p>
+            <a:pPr algn="ctr">
+              <a:lnSpc>
+                <a:spcPts val="1107"/>
+              </a:lnSpc>
+            </a:pPr>
+            <a:r>
+              <a:rPr sz="922" b="1" i="0">
                 <a:solidFill>
                   <a:srgbClr val="FFFFFF"/>
                 </a:solidFill>
@@ -6888,25 +6888,25 @@
         </p:nvSpPr>
         <p:spPr>
           <a:xfrm>
-            <a:off x="5385555" y="2175390"/>
-            <a:ext cx="536117" cy="173880"/>
-          </a:xfrm>
-          <a:prstGeom prst="rect">
-            <a:avLst/>
-          </a:prstGeom>
-          <a:noFill/>
-        </p:spPr>
-        <p:txBody>
-          <a:bodyPr wrap="none" lIns="0" rIns="0" tIns="0" bIns="0" anchor="t"/>
-          <a:lstStyle/>
-          <a:p>
-            <a:pPr algn="ctr">
-              <a:lnSpc>
-                <a:spcPts val="1357"/>
-              </a:lnSpc>
-            </a:pPr>
-            <a:r>
-              <a:rPr sz="1131" b="1" i="0">
+            <a:off x="5385555" y="2190510"/>
+            <a:ext cx="536117" cy="143640"/>
+          </a:xfrm>
+          <a:prstGeom prst="rect">
+            <a:avLst/>
+          </a:prstGeom>
+          <a:noFill/>
+        </p:spPr>
+        <p:txBody>
+          <a:bodyPr wrap="none" lIns="0" rIns="0" tIns="0" bIns="0" anchor="t"/>
+          <a:lstStyle/>
+          <a:p>
+            <a:pPr algn="ctr">
+              <a:lnSpc>
+                <a:spcPts val="1107"/>
+              </a:lnSpc>
+            </a:pPr>
+            <a:r>
+              <a:rPr sz="922" b="1" i="0">
                 <a:solidFill>
                   <a:srgbClr val="FFFFFF"/>
                 </a:solidFill>
@@ -6925,25 +6925,25 @@
         </p:nvSpPr>
         <p:spPr>
           <a:xfrm>
-            <a:off x="5946412" y="2175390"/>
-            <a:ext cx="536117" cy="173880"/>
-          </a:xfrm>
-          <a:prstGeom prst="rect">
-            <a:avLst/>
-          </a:prstGeom>
-          <a:noFill/>
-        </p:spPr>
-        <p:txBody>
-          <a:bodyPr wrap="none" lIns="0" rIns="0" tIns="0" bIns="0" anchor="t"/>
-          <a:lstStyle/>
-          <a:p>
-            <a:pPr algn="ctr">
-              <a:lnSpc>
-                <a:spcPts val="1357"/>
-              </a:lnSpc>
-            </a:pPr>
-            <a:r>
-              <a:rPr sz="1131" b="1" i="0">
+            <a:off x="5946412" y="2190510"/>
+            <a:ext cx="536117" cy="143640"/>
+          </a:xfrm>
+          <a:prstGeom prst="rect">
+            <a:avLst/>
+          </a:prstGeom>
+          <a:noFill/>
+        </p:spPr>
+        <p:txBody>
+          <a:bodyPr wrap="none" lIns="0" rIns="0" tIns="0" bIns="0" anchor="t"/>
+          <a:lstStyle/>
+          <a:p>
+            <a:pPr algn="ctr">
+              <a:lnSpc>
+                <a:spcPts val="1107"/>
+              </a:lnSpc>
+            </a:pPr>
+            <a:r>
+              <a:rPr sz="922" b="1" i="0">
                 <a:solidFill>
                   <a:srgbClr val="FFFFFF"/>
                 </a:solidFill>
@@ -6962,25 +6962,25 @@
         </p:nvSpPr>
         <p:spPr>
           <a:xfrm>
-            <a:off x="6507270" y="2175390"/>
-            <a:ext cx="536608" cy="173880"/>
-          </a:xfrm>
-          <a:prstGeom prst="rect">
-            <a:avLst/>
-          </a:prstGeom>
-          <a:noFill/>
-        </p:spPr>
-        <p:txBody>
-          <a:bodyPr wrap="none" lIns="0" rIns="0" tIns="0" bIns="0" anchor="t"/>
-          <a:lstStyle/>
-          <a:p>
-            <a:pPr algn="ctr">
-              <a:lnSpc>
-                <a:spcPts val="1357"/>
-              </a:lnSpc>
-            </a:pPr>
-            <a:r>
-              <a:rPr sz="1131" b="1" i="0">
+            <a:off x="6507270" y="2190510"/>
+            <a:ext cx="536608" cy="143640"/>
+          </a:xfrm>
+          <a:prstGeom prst="rect">
+            <a:avLst/>
+          </a:prstGeom>
+          <a:noFill/>
+        </p:spPr>
+        <p:txBody>
+          <a:bodyPr wrap="none" lIns="0" rIns="0" tIns="0" bIns="0" anchor="t"/>
+          <a:lstStyle/>
+          <a:p>
+            <a:pPr algn="ctr">
+              <a:lnSpc>
+                <a:spcPts val="1107"/>
+              </a:lnSpc>
+            </a:pPr>
+            <a:r>
+              <a:rPr sz="922" b="1" i="0">
                 <a:solidFill>
                   <a:srgbClr val="FFFFFF"/>
                 </a:solidFill>
@@ -7369,7 +7369,7 @@
         </p:nvSpPr>
         <p:spPr>
           <a:xfrm>
-            <a:off x="604800" y="3044199"/>
+            <a:off x="604800" y="3187366"/>
             <a:ext cx="1425060" cy="143640"/>
           </a:xfrm>
           <a:prstGeom prst="rect">
@@ -7406,7 +7406,7 @@
         </p:nvSpPr>
         <p:spPr>
           <a:xfrm>
-            <a:off x="2020410" y="3052822"/>
+            <a:off x="2020410" y="3195990"/>
             <a:ext cx="536117" cy="136080"/>
           </a:xfrm>
           <a:prstGeom prst="rect">
@@ -7443,7 +7443,7 @@
         </p:nvSpPr>
         <p:spPr>
           <a:xfrm>
-            <a:off x="2581267" y="3052822"/>
+            <a:off x="2581267" y="3195990"/>
             <a:ext cx="536117" cy="136080"/>
           </a:xfrm>
           <a:prstGeom prst="rect">
@@ -7480,7 +7480,7 @@
         </p:nvSpPr>
         <p:spPr>
           <a:xfrm>
-            <a:off x="3142125" y="3052822"/>
+            <a:off x="3142125" y="3195990"/>
             <a:ext cx="536117" cy="136080"/>
           </a:xfrm>
           <a:prstGeom prst="rect">
@@ -7517,7 +7517,7 @@
         </p:nvSpPr>
         <p:spPr>
           <a:xfrm>
-            <a:off x="3702982" y="3052822"/>
+            <a:off x="3702982" y="3195990"/>
             <a:ext cx="536117" cy="136080"/>
           </a:xfrm>
           <a:prstGeom prst="rect">
@@ -7554,7 +7554,7 @@
         </p:nvSpPr>
         <p:spPr>
           <a:xfrm>
-            <a:off x="4263840" y="3052822"/>
+            <a:off x="4263840" y="3195990"/>
             <a:ext cx="536117" cy="136080"/>
           </a:xfrm>
           <a:prstGeom prst="rect">
@@ -7591,7 +7591,7 @@
         </p:nvSpPr>
         <p:spPr>
           <a:xfrm>
-            <a:off x="4824697" y="3052822"/>
+            <a:off x="4824697" y="3195990"/>
             <a:ext cx="536117" cy="136080"/>
           </a:xfrm>
           <a:prstGeom prst="rect">
@@ -7628,7 +7628,7 @@
         </p:nvSpPr>
         <p:spPr>
           <a:xfrm>
-            <a:off x="5385555" y="3052822"/>
+            <a:off x="5385555" y="3195990"/>
             <a:ext cx="536117" cy="136080"/>
           </a:xfrm>
           <a:prstGeom prst="rect">
@@ -7665,7 +7665,7 @@
         </p:nvSpPr>
         <p:spPr>
           <a:xfrm>
-            <a:off x="5946412" y="3052822"/>
+            <a:off x="5946412" y="3195990"/>
             <a:ext cx="536117" cy="136080"/>
           </a:xfrm>
           <a:prstGeom prst="rect">
@@ -7702,7 +7702,7 @@
         </p:nvSpPr>
         <p:spPr>
           <a:xfrm>
-            <a:off x="6507270" y="3052822"/>
+            <a:off x="6507270" y="3195990"/>
             <a:ext cx="536608" cy="136080"/>
           </a:xfrm>
           <a:prstGeom prst="rect">
@@ -7739,7 +7739,7 @@
         </p:nvSpPr>
         <p:spPr>
           <a:xfrm>
-            <a:off x="604800" y="3339039"/>
+            <a:off x="604800" y="3768541"/>
             <a:ext cx="1425060" cy="143640"/>
           </a:xfrm>
           <a:prstGeom prst="rect">
@@ -7776,7 +7776,7 @@
         </p:nvSpPr>
         <p:spPr>
           <a:xfrm>
-            <a:off x="2020410" y="3347662"/>
+            <a:off x="2020410" y="3777165"/>
             <a:ext cx="536117" cy="136080"/>
           </a:xfrm>
           <a:prstGeom prst="rect">
@@ -7813,7 +7813,7 @@
         </p:nvSpPr>
         <p:spPr>
           <a:xfrm>
-            <a:off x="2581267" y="3347662"/>
+            <a:off x="2581267" y="3777165"/>
             <a:ext cx="536117" cy="136080"/>
           </a:xfrm>
           <a:prstGeom prst="rect">
@@ -7850,7 +7850,7 @@
         </p:nvSpPr>
         <p:spPr>
           <a:xfrm>
-            <a:off x="3142125" y="3347662"/>
+            <a:off x="3142125" y="3777165"/>
             <a:ext cx="536117" cy="136080"/>
           </a:xfrm>
           <a:prstGeom prst="rect">
@@ -7887,7 +7887,7 @@
         </p:nvSpPr>
         <p:spPr>
           <a:xfrm>
-            <a:off x="3702982" y="3347662"/>
+            <a:off x="3702982" y="3777165"/>
             <a:ext cx="536117" cy="136080"/>
           </a:xfrm>
           <a:prstGeom prst="rect">
@@ -7924,7 +7924,7 @@
         </p:nvSpPr>
         <p:spPr>
           <a:xfrm>
-            <a:off x="4263840" y="3347662"/>
+            <a:off x="4263840" y="3777165"/>
             <a:ext cx="536117" cy="136080"/>
           </a:xfrm>
           <a:prstGeom prst="rect">
@@ -7961,7 +7961,7 @@
         </p:nvSpPr>
         <p:spPr>
           <a:xfrm>
-            <a:off x="4824697" y="3347662"/>
+            <a:off x="4824697" y="3777165"/>
             <a:ext cx="536117" cy="136080"/>
           </a:xfrm>
           <a:prstGeom prst="rect">
@@ -7998,7 +7998,7 @@
         </p:nvSpPr>
         <p:spPr>
           <a:xfrm>
-            <a:off x="5385555" y="3347662"/>
+            <a:off x="5385555" y="3777165"/>
             <a:ext cx="536117" cy="136080"/>
           </a:xfrm>
           <a:prstGeom prst="rect">
@@ -8035,7 +8035,7 @@
         </p:nvSpPr>
         <p:spPr>
           <a:xfrm>
-            <a:off x="5946412" y="3347662"/>
+            <a:off x="5946412" y="3777165"/>
             <a:ext cx="536117" cy="136080"/>
           </a:xfrm>
           <a:prstGeom prst="rect">
@@ -8072,7 +8072,7 @@
         </p:nvSpPr>
         <p:spPr>
           <a:xfrm>
-            <a:off x="6507270" y="3347662"/>
+            <a:off x="6507270" y="3777165"/>
             <a:ext cx="536608" cy="136080"/>
           </a:xfrm>
           <a:prstGeom prst="rect">
@@ -8109,7 +8109,7 @@
         </p:nvSpPr>
         <p:spPr>
           <a:xfrm>
-            <a:off x="604800" y="3633879"/>
+            <a:off x="604800" y="4349716"/>
             <a:ext cx="1425060" cy="143640"/>
           </a:xfrm>
           <a:prstGeom prst="rect">
@@ -8146,7 +8146,7 @@
         </p:nvSpPr>
         <p:spPr>
           <a:xfrm>
-            <a:off x="2020410" y="3642502"/>
+            <a:off x="2020410" y="4358340"/>
             <a:ext cx="536117" cy="136080"/>
           </a:xfrm>
           <a:prstGeom prst="rect">
@@ -8183,7 +8183,7 @@
         </p:nvSpPr>
         <p:spPr>
           <a:xfrm>
-            <a:off x="2581267" y="3642502"/>
+            <a:off x="2581267" y="4358340"/>
             <a:ext cx="536117" cy="136080"/>
           </a:xfrm>
           <a:prstGeom prst="rect">
@@ -8220,7 +8220,7 @@
         </p:nvSpPr>
         <p:spPr>
           <a:xfrm>
-            <a:off x="3142125" y="3642502"/>
+            <a:off x="3142125" y="4358340"/>
             <a:ext cx="536117" cy="136080"/>
           </a:xfrm>
           <a:prstGeom prst="rect">
@@ -8257,7 +8257,7 @@
         </p:nvSpPr>
         <p:spPr>
           <a:xfrm>
-            <a:off x="3702982" y="3642502"/>
+            <a:off x="3702982" y="4358340"/>
             <a:ext cx="536117" cy="136080"/>
           </a:xfrm>
           <a:prstGeom prst="rect">
@@ -8294,7 +8294,7 @@
         </p:nvSpPr>
         <p:spPr>
           <a:xfrm>
-            <a:off x="4263840" y="3642502"/>
+            <a:off x="4263840" y="4358340"/>
             <a:ext cx="536117" cy="136080"/>
           </a:xfrm>
           <a:prstGeom prst="rect">
@@ -8331,7 +8331,7 @@
         </p:nvSpPr>
         <p:spPr>
           <a:xfrm>
-            <a:off x="4824697" y="3642502"/>
+            <a:off x="4824697" y="4358340"/>
             <a:ext cx="536117" cy="136080"/>
           </a:xfrm>
           <a:prstGeom prst="rect">
@@ -8368,7 +8368,7 @@
         </p:nvSpPr>
         <p:spPr>
           <a:xfrm>
-            <a:off x="5385555" y="3642502"/>
+            <a:off x="5385555" y="4358340"/>
             <a:ext cx="536117" cy="136080"/>
           </a:xfrm>
           <a:prstGeom prst="rect">
@@ -8405,7 +8405,7 @@
         </p:nvSpPr>
         <p:spPr>
           <a:xfrm>
-            <a:off x="5946412" y="3642502"/>
+            <a:off x="5946412" y="4358340"/>
             <a:ext cx="536117" cy="136080"/>
           </a:xfrm>
           <a:prstGeom prst="rect">
@@ -8442,7 +8442,7 @@
         </p:nvSpPr>
         <p:spPr>
           <a:xfrm>
-            <a:off x="6507270" y="3642502"/>
+            <a:off x="6507270" y="4358340"/>
             <a:ext cx="536608" cy="136080"/>
           </a:xfrm>
           <a:prstGeom prst="rect">
@@ -8479,7 +8479,7 @@
         </p:nvSpPr>
         <p:spPr>
           <a:xfrm>
-            <a:off x="604800" y="3928719"/>
+            <a:off x="604800" y="4930891"/>
             <a:ext cx="1425060" cy="143640"/>
           </a:xfrm>
           <a:prstGeom prst="rect">
@@ -8516,7 +8516,7 @@
         </p:nvSpPr>
         <p:spPr>
           <a:xfrm>
-            <a:off x="2020410" y="3937342"/>
+            <a:off x="2020410" y="4939515"/>
             <a:ext cx="536117" cy="136080"/>
           </a:xfrm>
           <a:prstGeom prst="rect">
@@ -8553,7 +8553,7 @@
         </p:nvSpPr>
         <p:spPr>
           <a:xfrm>
-            <a:off x="2581267" y="3937342"/>
+            <a:off x="2581267" y="4939515"/>
             <a:ext cx="536117" cy="136080"/>
           </a:xfrm>
           <a:prstGeom prst="rect">
@@ -8590,7 +8590,7 @@
         </p:nvSpPr>
         <p:spPr>
           <a:xfrm>
-            <a:off x="3142125" y="3937342"/>
+            <a:off x="3142125" y="4939515"/>
             <a:ext cx="536117" cy="136080"/>
           </a:xfrm>
           <a:prstGeom prst="rect">
@@ -8627,7 +8627,7 @@
         </p:nvSpPr>
         <p:spPr>
           <a:xfrm>
-            <a:off x="3702982" y="3937342"/>
+            <a:off x="3702982" y="4939515"/>
             <a:ext cx="536117" cy="136080"/>
           </a:xfrm>
           <a:prstGeom prst="rect">
@@ -8664,7 +8664,7 @@
         </p:nvSpPr>
         <p:spPr>
           <a:xfrm>
-            <a:off x="4263840" y="3937342"/>
+            <a:off x="4263840" y="4939515"/>
             <a:ext cx="536117" cy="136080"/>
           </a:xfrm>
           <a:prstGeom prst="rect">
@@ -8701,7 +8701,7 @@
         </p:nvSpPr>
         <p:spPr>
           <a:xfrm>
-            <a:off x="4824697" y="3937342"/>
+            <a:off x="4824697" y="4939515"/>
             <a:ext cx="536117" cy="136080"/>
           </a:xfrm>
           <a:prstGeom prst="rect">
@@ -8738,7 +8738,7 @@
         </p:nvSpPr>
         <p:spPr>
           <a:xfrm>
-            <a:off x="5385555" y="3937342"/>
+            <a:off x="5385555" y="4939515"/>
             <a:ext cx="536117" cy="136080"/>
           </a:xfrm>
           <a:prstGeom prst="rect">
@@ -8775,7 +8775,7 @@
         </p:nvSpPr>
         <p:spPr>
           <a:xfrm>
-            <a:off x="5946412" y="3937342"/>
+            <a:off x="5946412" y="4939515"/>
             <a:ext cx="536117" cy="136080"/>
           </a:xfrm>
           <a:prstGeom prst="rect">
@@ -8812,7 +8812,7 @@
         </p:nvSpPr>
         <p:spPr>
           <a:xfrm>
-            <a:off x="6507270" y="3937342"/>
+            <a:off x="6507270" y="4939515"/>
             <a:ext cx="536608" cy="136080"/>
           </a:xfrm>
           <a:prstGeom prst="rect">
@@ -8849,7 +8849,7 @@
         </p:nvSpPr>
         <p:spPr>
           <a:xfrm>
-            <a:off x="604800" y="4223559"/>
+            <a:off x="604800" y="5512066"/>
             <a:ext cx="1425060" cy="143640"/>
           </a:xfrm>
           <a:prstGeom prst="rect">
@@ -8886,7 +8886,7 @@
         </p:nvSpPr>
         <p:spPr>
           <a:xfrm>
-            <a:off x="2020410" y="4232182"/>
+            <a:off x="2020410" y="5520690"/>
             <a:ext cx="536117" cy="136080"/>
           </a:xfrm>
           <a:prstGeom prst="rect">
@@ -8923,7 +8923,7 @@
         </p:nvSpPr>
         <p:spPr>
           <a:xfrm>
-            <a:off x="2581267" y="4232182"/>
+            <a:off x="2581267" y="5520690"/>
             <a:ext cx="536117" cy="136080"/>
           </a:xfrm>
           <a:prstGeom prst="rect">
@@ -8960,7 +8960,7 @@
         </p:nvSpPr>
         <p:spPr>
           <a:xfrm>
-            <a:off x="3142125" y="4232182"/>
+            <a:off x="3142125" y="5520690"/>
             <a:ext cx="536117" cy="136080"/>
           </a:xfrm>
           <a:prstGeom prst="rect">
@@ -8997,7 +8997,7 @@
         </p:nvSpPr>
         <p:spPr>
           <a:xfrm>
-            <a:off x="3702982" y="4232182"/>
+            <a:off x="3702982" y="5520690"/>
             <a:ext cx="536117" cy="136080"/>
           </a:xfrm>
           <a:prstGeom prst="rect">
@@ -9034,7 +9034,7 @@
         </p:nvSpPr>
         <p:spPr>
           <a:xfrm>
-            <a:off x="4263840" y="4232182"/>
+            <a:off x="4263840" y="5520690"/>
             <a:ext cx="536117" cy="136080"/>
           </a:xfrm>
           <a:prstGeom prst="rect">
@@ -9071,7 +9071,7 @@
         </p:nvSpPr>
         <p:spPr>
           <a:xfrm>
-            <a:off x="4824697" y="4232182"/>
+            <a:off x="4824697" y="5520690"/>
             <a:ext cx="536117" cy="136080"/>
           </a:xfrm>
           <a:prstGeom prst="rect">
@@ -9108,7 +9108,7 @@
         </p:nvSpPr>
         <p:spPr>
           <a:xfrm>
-            <a:off x="5385555" y="4232182"/>
+            <a:off x="5385555" y="5520690"/>
             <a:ext cx="536117" cy="136080"/>
           </a:xfrm>
           <a:prstGeom prst="rect">
@@ -9145,7 +9145,7 @@
         </p:nvSpPr>
         <p:spPr>
           <a:xfrm>
-            <a:off x="5946412" y="4232182"/>
+            <a:off x="5946412" y="5520690"/>
             <a:ext cx="536117" cy="136080"/>
           </a:xfrm>
           <a:prstGeom prst="rect">
@@ -9182,7 +9182,7 @@
         </p:nvSpPr>
         <p:spPr>
           <a:xfrm>
-            <a:off x="6507270" y="4232182"/>
+            <a:off x="6507270" y="5520690"/>
             <a:ext cx="536608" cy="136080"/>
           </a:xfrm>
           <a:prstGeom prst="rect">
@@ -9219,7 +9219,7 @@
         </p:nvSpPr>
         <p:spPr>
           <a:xfrm>
-            <a:off x="604800" y="4518399"/>
+            <a:off x="604800" y="6093241"/>
             <a:ext cx="1425060" cy="143640"/>
           </a:xfrm>
           <a:prstGeom prst="rect">
@@ -9256,7 +9256,7 @@
         </p:nvSpPr>
         <p:spPr>
           <a:xfrm>
-            <a:off x="2020410" y="4527022"/>
+            <a:off x="2020410" y="6101865"/>
             <a:ext cx="536117" cy="136080"/>
           </a:xfrm>
           <a:prstGeom prst="rect">
@@ -9293,7 +9293,7 @@
         </p:nvSpPr>
         <p:spPr>
           <a:xfrm>
-            <a:off x="2581267" y="4527022"/>
+            <a:off x="2581267" y="6101865"/>
             <a:ext cx="536117" cy="136080"/>
           </a:xfrm>
           <a:prstGeom prst="rect">
@@ -9330,7 +9330,7 @@
         </p:nvSpPr>
         <p:spPr>
           <a:xfrm>
-            <a:off x="3142125" y="4527022"/>
+            <a:off x="3142125" y="6101865"/>
             <a:ext cx="536117" cy="136080"/>
           </a:xfrm>
           <a:prstGeom prst="rect">
@@ -9367,7 +9367,7 @@
         </p:nvSpPr>
         <p:spPr>
           <a:xfrm>
-            <a:off x="3702982" y="4527022"/>
+            <a:off x="3702982" y="6101865"/>
             <a:ext cx="536117" cy="136080"/>
           </a:xfrm>
           <a:prstGeom prst="rect">
@@ -9404,7 +9404,7 @@
         </p:nvSpPr>
         <p:spPr>
           <a:xfrm>
-            <a:off x="4263840" y="4527022"/>
+            <a:off x="4263840" y="6101865"/>
             <a:ext cx="536117" cy="136080"/>
           </a:xfrm>
           <a:prstGeom prst="rect">
@@ -9441,7 +9441,7 @@
         </p:nvSpPr>
         <p:spPr>
           <a:xfrm>
-            <a:off x="4824697" y="4527022"/>
+            <a:off x="4824697" y="6101865"/>
             <a:ext cx="536117" cy="136080"/>
           </a:xfrm>
           <a:prstGeom prst="rect">
@@ -9478,7 +9478,7 @@
         </p:nvSpPr>
         <p:spPr>
           <a:xfrm>
-            <a:off x="5385555" y="4527022"/>
+            <a:off x="5385555" y="6101865"/>
             <a:ext cx="536117" cy="136080"/>
           </a:xfrm>
           <a:prstGeom prst="rect">
@@ -9515,7 +9515,7 @@
         </p:nvSpPr>
         <p:spPr>
           <a:xfrm>
-            <a:off x="5946412" y="4527022"/>
+            <a:off x="5946412" y="6101865"/>
             <a:ext cx="536117" cy="136080"/>
           </a:xfrm>
           <a:prstGeom prst="rect">
@@ -9552,7 +9552,7 @@
         </p:nvSpPr>
         <p:spPr>
           <a:xfrm>
-            <a:off x="6507270" y="4527022"/>
+            <a:off x="6507270" y="6101865"/>
             <a:ext cx="536608" cy="136080"/>
           </a:xfrm>
           <a:prstGeom prst="rect">
@@ -9589,7 +9589,7 @@
         </p:nvSpPr>
         <p:spPr>
           <a:xfrm>
-            <a:off x="604800" y="4813239"/>
+            <a:off x="604800" y="6674416"/>
             <a:ext cx="1425060" cy="143640"/>
           </a:xfrm>
           <a:prstGeom prst="rect">
@@ -9626,7 +9626,7 @@
         </p:nvSpPr>
         <p:spPr>
           <a:xfrm>
-            <a:off x="2020410" y="4821862"/>
+            <a:off x="2020410" y="6683040"/>
             <a:ext cx="536117" cy="136080"/>
           </a:xfrm>
           <a:prstGeom prst="rect">
@@ -9663,7 +9663,7 @@
         </p:nvSpPr>
         <p:spPr>
           <a:xfrm>
-            <a:off x="2581267" y="4821862"/>
+            <a:off x="2581267" y="6683040"/>
             <a:ext cx="536117" cy="136080"/>
           </a:xfrm>
           <a:prstGeom prst="rect">
@@ -9700,7 +9700,7 @@
         </p:nvSpPr>
         <p:spPr>
           <a:xfrm>
-            <a:off x="3142125" y="4821862"/>
+            <a:off x="3142125" y="6683040"/>
             <a:ext cx="536117" cy="136080"/>
           </a:xfrm>
           <a:prstGeom prst="rect">
@@ -9737,7 +9737,7 @@
         </p:nvSpPr>
         <p:spPr>
           <a:xfrm>
-            <a:off x="3702982" y="4821862"/>
+            <a:off x="3702982" y="6683040"/>
             <a:ext cx="536117" cy="136080"/>
           </a:xfrm>
           <a:prstGeom prst="rect">
@@ -9774,7 +9774,7 @@
         </p:nvSpPr>
         <p:spPr>
           <a:xfrm>
-            <a:off x="4263840" y="4821862"/>
+            <a:off x="4263840" y="6683040"/>
             <a:ext cx="536117" cy="136080"/>
           </a:xfrm>
           <a:prstGeom prst="rect">
@@ -9811,7 +9811,7 @@
         </p:nvSpPr>
         <p:spPr>
           <a:xfrm>
-            <a:off x="4824697" y="4821862"/>
+            <a:off x="4824697" y="6683040"/>
             <a:ext cx="536117" cy="136080"/>
           </a:xfrm>
           <a:prstGeom prst="rect">
@@ -9848,7 +9848,7 @@
         </p:nvSpPr>
         <p:spPr>
           <a:xfrm>
-            <a:off x="5385555" y="4821862"/>
+            <a:off x="5385555" y="6683040"/>
             <a:ext cx="536117" cy="136080"/>
           </a:xfrm>
           <a:prstGeom prst="rect">
@@ -9885,7 +9885,7 @@
         </p:nvSpPr>
         <p:spPr>
           <a:xfrm>
-            <a:off x="5946412" y="4821862"/>
+            <a:off x="5946412" y="6683040"/>
             <a:ext cx="536117" cy="136080"/>
           </a:xfrm>
           <a:prstGeom prst="rect">
@@ -9922,7 +9922,7 @@
         </p:nvSpPr>
         <p:spPr>
           <a:xfrm>
-            <a:off x="6507270" y="4821862"/>
+            <a:off x="6507270" y="6683040"/>
             <a:ext cx="536608" cy="136080"/>
           </a:xfrm>
           <a:prstGeom prst="rect">
@@ -9959,7 +9959,7 @@
         </p:nvSpPr>
         <p:spPr>
           <a:xfrm>
-            <a:off x="604800" y="5108079"/>
+            <a:off x="604800" y="7255591"/>
             <a:ext cx="1425060" cy="143640"/>
           </a:xfrm>
           <a:prstGeom prst="rect">
@@ -9996,7 +9996,7 @@
         </p:nvSpPr>
         <p:spPr>
           <a:xfrm>
-            <a:off x="2020410" y="5116702"/>
+            <a:off x="2020410" y="7264215"/>
             <a:ext cx="536117" cy="136080"/>
           </a:xfrm>
           <a:prstGeom prst="rect">
@@ -10033,7 +10033,7 @@
         </p:nvSpPr>
         <p:spPr>
           <a:xfrm>
-            <a:off x="2581267" y="5116702"/>
+            <a:off x="2581267" y="7264215"/>
             <a:ext cx="536117" cy="136080"/>
           </a:xfrm>
           <a:prstGeom prst="rect">
@@ -10070,7 +10070,7 @@
         </p:nvSpPr>
         <p:spPr>
           <a:xfrm>
-            <a:off x="3142125" y="5116702"/>
+            <a:off x="3142125" y="7264215"/>
             <a:ext cx="536117" cy="136080"/>
           </a:xfrm>
           <a:prstGeom prst="rect">
@@ -10107,7 +10107,7 @@
         </p:nvSpPr>
         <p:spPr>
           <a:xfrm>
-            <a:off x="3702982" y="5116702"/>
+            <a:off x="3702982" y="7264215"/>
             <a:ext cx="536117" cy="136080"/>
           </a:xfrm>
           <a:prstGeom prst="rect">
@@ -10144,7 +10144,7 @@
         </p:nvSpPr>
         <p:spPr>
           <a:xfrm>
-            <a:off x="4263840" y="5116702"/>
+            <a:off x="4263840" y="7264215"/>
             <a:ext cx="536117" cy="136080"/>
           </a:xfrm>
           <a:prstGeom prst="rect">
@@ -10181,7 +10181,7 @@
         </p:nvSpPr>
         <p:spPr>
           <a:xfrm>
-            <a:off x="4824697" y="5116702"/>
+            <a:off x="4824697" y="7264215"/>
             <a:ext cx="536117" cy="136080"/>
           </a:xfrm>
           <a:prstGeom prst="rect">
@@ -10218,7 +10218,7 @@
         </p:nvSpPr>
         <p:spPr>
           <a:xfrm>
-            <a:off x="5385555" y="5116702"/>
+            <a:off x="5385555" y="7264215"/>
             <a:ext cx="536117" cy="136080"/>
           </a:xfrm>
           <a:prstGeom prst="rect">
@@ -10255,7 +10255,7 @@
         </p:nvSpPr>
         <p:spPr>
           <a:xfrm>
-            <a:off x="5946412" y="5116702"/>
+            <a:off x="5946412" y="7264215"/>
             <a:ext cx="536117" cy="136080"/>
           </a:xfrm>
           <a:prstGeom prst="rect">
@@ -10292,7 +10292,7 @@
         </p:nvSpPr>
         <p:spPr>
           <a:xfrm>
-            <a:off x="6507270" y="5116702"/>
+            <a:off x="6507270" y="7264215"/>
             <a:ext cx="536608" cy="136080"/>
           </a:xfrm>
           <a:prstGeom prst="rect">
@@ -10329,7 +10329,7 @@
         </p:nvSpPr>
         <p:spPr>
           <a:xfrm>
-            <a:off x="604800" y="5402919"/>
+            <a:off x="604800" y="7836766"/>
             <a:ext cx="1425060" cy="143640"/>
           </a:xfrm>
           <a:prstGeom prst="rect">
@@ -10366,7 +10366,7 @@
         </p:nvSpPr>
         <p:spPr>
           <a:xfrm>
-            <a:off x="2020410" y="5411542"/>
+            <a:off x="2020410" y="7845390"/>
             <a:ext cx="536117" cy="136080"/>
           </a:xfrm>
           <a:prstGeom prst="rect">
@@ -10403,7 +10403,7 @@
         </p:nvSpPr>
         <p:spPr>
           <a:xfrm>
-            <a:off x="2581267" y="5411542"/>
+            <a:off x="2581267" y="7845390"/>
             <a:ext cx="536117" cy="136080"/>
           </a:xfrm>
           <a:prstGeom prst="rect">
@@ -10440,7 +10440,7 @@
         </p:nvSpPr>
         <p:spPr>
           <a:xfrm>
-            <a:off x="3142125" y="5411542"/>
+            <a:off x="3142125" y="7845390"/>
             <a:ext cx="536117" cy="136080"/>
           </a:xfrm>
           <a:prstGeom prst="rect">
@@ -10477,7 +10477,7 @@
         </p:nvSpPr>
         <p:spPr>
           <a:xfrm>
-            <a:off x="3702982" y="5411542"/>
+            <a:off x="3702982" y="7845390"/>
             <a:ext cx="536117" cy="136080"/>
           </a:xfrm>
           <a:prstGeom prst="rect">
@@ -10514,7 +10514,7 @@
         </p:nvSpPr>
         <p:spPr>
           <a:xfrm>
-            <a:off x="4263840" y="5411542"/>
+            <a:off x="4263840" y="7845390"/>
             <a:ext cx="536117" cy="136080"/>
           </a:xfrm>
           <a:prstGeom prst="rect">
@@ -10551,7 +10551,7 @@
         </p:nvSpPr>
         <p:spPr>
           <a:xfrm>
-            <a:off x="4824697" y="5411542"/>
+            <a:off x="4824697" y="7845390"/>
             <a:ext cx="536117" cy="136080"/>
           </a:xfrm>
           <a:prstGeom prst="rect">
@@ -10588,7 +10588,7 @@
         </p:nvSpPr>
         <p:spPr>
           <a:xfrm>
-            <a:off x="5385555" y="5411542"/>
+            <a:off x="5385555" y="7845390"/>
             <a:ext cx="536117" cy="136080"/>
           </a:xfrm>
           <a:prstGeom prst="rect">
@@ -10625,7 +10625,7 @@
         </p:nvSpPr>
         <p:spPr>
           <a:xfrm>
-            <a:off x="5946412" y="5411542"/>
+            <a:off x="5946412" y="7845390"/>
             <a:ext cx="536117" cy="136080"/>
           </a:xfrm>
           <a:prstGeom prst="rect">
@@ -10662,7 +10662,7 @@
         </p:nvSpPr>
         <p:spPr>
           <a:xfrm>
-            <a:off x="6507270" y="5411542"/>
+            <a:off x="6507270" y="7845390"/>
             <a:ext cx="536608" cy="136080"/>
           </a:xfrm>
           <a:prstGeom prst="rect">
@@ -10699,7 +10699,7 @@
         </p:nvSpPr>
         <p:spPr>
           <a:xfrm>
-            <a:off x="604800" y="5697759"/>
+            <a:off x="604800" y="8417941"/>
             <a:ext cx="1425060" cy="143640"/>
           </a:xfrm>
           <a:prstGeom prst="rect">
@@ -10736,7 +10736,7 @@
         </p:nvSpPr>
         <p:spPr>
           <a:xfrm>
-            <a:off x="2020410" y="5706382"/>
+            <a:off x="2020410" y="8426565"/>
             <a:ext cx="536117" cy="136080"/>
           </a:xfrm>
           <a:prstGeom prst="rect">
@@ -10773,7 +10773,7 @@
         </p:nvSpPr>
         <p:spPr>
           <a:xfrm>
-            <a:off x="2581267" y="5706382"/>
+            <a:off x="2581267" y="8426565"/>
             <a:ext cx="536117" cy="136080"/>
           </a:xfrm>
           <a:prstGeom prst="rect">
@@ -10810,7 +10810,7 @@
         </p:nvSpPr>
         <p:spPr>
           <a:xfrm>
-            <a:off x="3142125" y="5706382"/>
+            <a:off x="3142125" y="8426565"/>
             <a:ext cx="536117" cy="136080"/>
           </a:xfrm>
           <a:prstGeom prst="rect">
@@ -10847,7 +10847,7 @@
         </p:nvSpPr>
         <p:spPr>
           <a:xfrm>
-            <a:off x="3702982" y="5706382"/>
+            <a:off x="3702982" y="8426565"/>
             <a:ext cx="536117" cy="136080"/>
           </a:xfrm>
           <a:prstGeom prst="rect">
@@ -10884,7 +10884,7 @@
         </p:nvSpPr>
         <p:spPr>
           <a:xfrm>
-            <a:off x="4263840" y="5706382"/>
+            <a:off x="4263840" y="8426565"/>
             <a:ext cx="536117" cy="136080"/>
           </a:xfrm>
           <a:prstGeom prst="rect">
@@ -10921,7 +10921,7 @@
         </p:nvSpPr>
         <p:spPr>
           <a:xfrm>
-            <a:off x="4824697" y="5706382"/>
+            <a:off x="4824697" y="8426565"/>
             <a:ext cx="536117" cy="136080"/>
           </a:xfrm>
           <a:prstGeom prst="rect">
@@ -10958,7 +10958,7 @@
         </p:nvSpPr>
         <p:spPr>
           <a:xfrm>
-            <a:off x="5385555" y="5706382"/>
+            <a:off x="5385555" y="8426565"/>
             <a:ext cx="536117" cy="136080"/>
           </a:xfrm>
           <a:prstGeom prst="rect">
@@ -10995,7 +10995,7 @@
         </p:nvSpPr>
         <p:spPr>
           <a:xfrm>
-            <a:off x="5946412" y="5706382"/>
+            <a:off x="5946412" y="8426565"/>
             <a:ext cx="536117" cy="136080"/>
           </a:xfrm>
           <a:prstGeom prst="rect">
@@ -11032,7 +11032,7 @@
         </p:nvSpPr>
         <p:spPr>
           <a:xfrm>
-            <a:off x="6507270" y="5706382"/>
+            <a:off x="6507270" y="8426565"/>
             <a:ext cx="536608" cy="136080"/>
           </a:xfrm>
           <a:prstGeom prst="rect">
@@ -11069,7 +11069,7 @@
         </p:nvSpPr>
         <p:spPr>
           <a:xfrm>
-            <a:off x="604800" y="5992599"/>
+            <a:off x="604800" y="8999707"/>
             <a:ext cx="1425060" cy="143640"/>
           </a:xfrm>
           <a:prstGeom prst="rect">
@@ -11106,7 +11106,7 @@
         </p:nvSpPr>
         <p:spPr>
           <a:xfrm>
-            <a:off x="2020410" y="6001222"/>
+            <a:off x="2020410" y="9008330"/>
             <a:ext cx="536117" cy="136080"/>
           </a:xfrm>
           <a:prstGeom prst="rect">
@@ -11143,7 +11143,7 @@
         </p:nvSpPr>
         <p:spPr>
           <a:xfrm>
-            <a:off x="2581267" y="6001222"/>
+            <a:off x="2581267" y="9008330"/>
             <a:ext cx="536117" cy="136080"/>
           </a:xfrm>
           <a:prstGeom prst="rect">
@@ -11180,7 +11180,7 @@
         </p:nvSpPr>
         <p:spPr>
           <a:xfrm>
-            <a:off x="3142125" y="6001222"/>
+            <a:off x="3142125" y="9008330"/>
             <a:ext cx="536117" cy="136080"/>
           </a:xfrm>
           <a:prstGeom prst="rect">
@@ -11217,7 +11217,7 @@
         </p:nvSpPr>
         <p:spPr>
           <a:xfrm>
-            <a:off x="3702982" y="6001222"/>
+            <a:off x="3702982" y="9008330"/>
             <a:ext cx="536117" cy="136080"/>
           </a:xfrm>
           <a:prstGeom prst="rect">
@@ -11254,7 +11254,7 @@
         </p:nvSpPr>
         <p:spPr>
           <a:xfrm>
-            <a:off x="4263840" y="6001222"/>
+            <a:off x="4263840" y="9008330"/>
             <a:ext cx="536117" cy="136080"/>
           </a:xfrm>
           <a:prstGeom prst="rect">
@@ -11291,7 +11291,7 @@
         </p:nvSpPr>
         <p:spPr>
           <a:xfrm>
-            <a:off x="4824697" y="6001222"/>
+            <a:off x="4824697" y="9008330"/>
             <a:ext cx="536117" cy="136080"/>
           </a:xfrm>
           <a:prstGeom prst="rect">
@@ -11328,7 +11328,7 @@
         </p:nvSpPr>
         <p:spPr>
           <a:xfrm>
-            <a:off x="5385555" y="6001222"/>
+            <a:off x="5385555" y="9008330"/>
             <a:ext cx="536117" cy="136080"/>
           </a:xfrm>
           <a:prstGeom prst="rect">
@@ -11365,7 +11365,7 @@
         </p:nvSpPr>
         <p:spPr>
           <a:xfrm>
-            <a:off x="5946412" y="6001222"/>
+            <a:off x="5946412" y="9008330"/>
             <a:ext cx="536117" cy="136080"/>
           </a:xfrm>
           <a:prstGeom prst="rect">
@@ -11402,7 +11402,7 @@
         </p:nvSpPr>
         <p:spPr>
           <a:xfrm>
-            <a:off x="6507270" y="6001222"/>
+            <a:off x="6507270" y="9008330"/>
             <a:ext cx="536608" cy="136080"/>
           </a:xfrm>
           <a:prstGeom prst="rect">

</xml_diff>

<commit_message>
AutomaTivio: razão social e CNPJ dos fundos de Crédito Privado
- configs/fundos.yml: razao_social de Institucional, Institucional 15,
  Infra Plus, Infra Plus CDI, Esplanada, Legacy e RF CP.
- Legacy: cnpj_exibido 09.166.056/0001-95 no cabeçalho (a DePara tem
  09.083.848/0001-04, que segue sendo usado para buscar as taxas).
- Cabeçalho: a linha da razão social diminui o corpo conforme o tamanho,
  para caber numa linha até o fim do traço.

Co-Authored-By: Claude Opus 5.5 <noreply@anthropic.com>
</commit_message>
<xml_diff>
--- a/AutomaTivio/saida/2026-08/pptx/Tivio Esplanada - Relatório de Gestão - Agosto 2026.pptx
+++ b/AutomaTivio/saida/2026-08/pptx/Tivio Esplanada - Relatório de Gestão - Agosto 2026.pptx
@@ -3124,7 +3124,7 @@
         <p:spPr>
           <a:xfrm>
             <a:off x="400680" y="748440"/>
-            <a:ext cx="6266332" cy="151200"/>
+            <a:ext cx="6266332" cy="143640"/>
           </a:xfrm>
           <a:prstGeom prst="rect">
             <a:avLst/>
@@ -3137,20 +3137,20 @@
           <a:p>
             <a:pPr algn="l">
               <a:lnSpc>
-                <a:spcPts val="1214"/>
-              </a:lnSpc>
-            </a:pPr>
-            <a:r>
-              <a:rPr sz="1012" b="0" i="0">
-                <a:solidFill>
-                  <a:srgbClr val="FFFFFF"/>
-                </a:solidFill>
-                <a:latin typeface="Versos"/>
-              </a:rPr>
-              <a:t>TIVIO ESPLANADA </a:t>
-            </a:r>
-            <a:r>
-              <a:rPr sz="833" b="0" i="0">
+                <a:spcPts val="1142"/>
+              </a:lnSpc>
+            </a:pPr>
+            <a:r>
+              <a:rPr sz="952" b="0" i="0">
+                <a:solidFill>
+                  <a:srgbClr val="FFFFFF"/>
+                </a:solidFill>
+                <a:latin typeface="Versos"/>
+              </a:rPr>
+              <a:t>TIVIO ESPLANADA RESP LIMITADA FIF FI INFRA RENDA FIXA </a:t>
+            </a:r>
+            <a:r>
+              <a:rPr sz="781" b="0" i="0">
                 <a:solidFill>
                   <a:srgbClr val="FFFFFF"/>
                 </a:solidFill>
@@ -3169,7 +3169,7 @@
         </p:nvSpPr>
         <p:spPr>
           <a:xfrm>
-            <a:off x="400680" y="1126440"/>
+            <a:off x="400680" y="1118880"/>
             <a:ext cx="6266332" cy="189000"/>
           </a:xfrm>
           <a:prstGeom prst="rect">

</xml_diff>